<commit_message>
added Siebel, small corrections
</commit_message>
<xml_diff>
--- a/statistics_08_F_ANOVA.pptx
+++ b/statistics_08_F_ANOVA.pptx
@@ -14935,7 +14935,7 @@
         </p:blipFill>
         <p:spPr>
           <a:xfrm>
-            <a:off x="10111939" y="114168"/>
+            <a:off x="10624003" y="114168"/>
             <a:ext cx="1328928" cy="1560576"/>
           </a:xfrm>
           <a:prstGeom prst="rect">
@@ -14971,7 +14971,7 @@
         </p:blipFill>
         <p:spPr>
           <a:xfrm>
-            <a:off x="5952067" y="114168"/>
+            <a:off x="8378275" y="114168"/>
             <a:ext cx="2057400" cy="3162300"/>
           </a:xfrm>
           <a:prstGeom prst="rect">
@@ -14993,7 +14993,7 @@
         </p:nvSpPr>
         <p:spPr>
           <a:xfrm>
-            <a:off x="6662714" y="3276468"/>
+            <a:off x="8576858" y="3276468"/>
             <a:ext cx="636105" cy="307777"/>
           </a:xfrm>
           <a:prstGeom prst="rect">
@@ -15042,7 +15042,7 @@
         </p:blipFill>
         <p:spPr>
           <a:xfrm>
-            <a:off x="9992669" y="1812235"/>
+            <a:off x="10504733" y="1812235"/>
             <a:ext cx="1616964" cy="2155952"/>
           </a:xfrm>
           <a:prstGeom prst="rect">
@@ -15078,7 +15078,7 @@
         </p:blipFill>
         <p:spPr>
           <a:xfrm>
-            <a:off x="9992669" y="4105678"/>
+            <a:off x="10504733" y="4105678"/>
             <a:ext cx="1640127" cy="2272748"/>
           </a:xfrm>
           <a:prstGeom prst="rect">
@@ -15114,7 +15114,7 @@
         </p:blipFill>
         <p:spPr>
           <a:xfrm>
-            <a:off x="6786718" y="3968187"/>
+            <a:off x="7298782" y="3968187"/>
             <a:ext cx="2667000" cy="2743200"/>
           </a:xfrm>
           <a:prstGeom prst="rect">
@@ -15150,8 +15150,8 @@
         </p:blipFill>
         <p:spPr>
           <a:xfrm>
-            <a:off x="1447912" y="2100903"/>
-            <a:ext cx="2104820" cy="1578615"/>
+            <a:off x="6541380" y="1086961"/>
+            <a:ext cx="1567420" cy="1175565"/>
           </a:xfrm>
           <a:prstGeom prst="rect">
             <a:avLst/>
@@ -15172,7 +15172,7 @@
         </p:nvSpPr>
         <p:spPr>
           <a:xfrm>
-            <a:off x="97999" y="4216178"/>
+            <a:off x="47140" y="1812235"/>
             <a:ext cx="5813155" cy="2462213"/>
           </a:xfrm>
           <a:prstGeom prst="rect">
@@ -15231,7 +15231,7 @@
           <a:p>
             <a:r>
               <a:rPr lang="en-US" dirty="0"/>
-              <a:t>If she guessed 3 out of 4, the probability is 0.22 – not good</a:t>
+              <a:t>If she guessed 3 out of 4, the probability is 16/70 = 0.22 – not good</a:t>
             </a:r>
           </a:p>
           <a:p>
@@ -15239,6 +15239,505 @@
               <a:rPr lang="en-US" dirty="0"/>
               <a:t>If she guessed 4 out of 4 – the probability is 1/70 &lt; 0.05 - good</a:t>
             </a:r>
+          </a:p>
+        </p:txBody>
+      </p:sp>
+      <p:sp>
+        <p:nvSpPr>
+          <p:cNvPr id="14" name="TextBox 13">
+            <a:extLst>
+              <a:ext uri="{FF2B5EF4-FFF2-40B4-BE49-F238E27FC236}">
+                <a16:creationId xmlns:a16="http://schemas.microsoft.com/office/drawing/2014/main" id="{484816C1-C588-2A46-A6ED-BDB416A2F4A0}"/>
+              </a:ext>
+            </a:extLst>
+          </p:cNvPr>
+          <p:cNvSpPr txBox="1"/>
+          <p:nvPr/>
+        </p:nvSpPr>
+        <p:spPr>
+          <a:xfrm>
+            <a:off x="93479" y="4469520"/>
+            <a:ext cx="6040637" cy="2123658"/>
+          </a:xfrm>
+          <a:prstGeom prst="rect">
+            <a:avLst/>
+          </a:prstGeom>
+          <a:noFill/>
+        </p:spPr>
+        <p:txBody>
+          <a:bodyPr wrap="square" rtlCol="0">
+            <a:spAutoFit/>
+          </a:bodyPr>
+          <a:lstStyle/>
+          <a:p>
+            <a:r>
+              <a:rPr lang="en-US" sz="1200" b="1" dirty="0">
+                <a:solidFill>
+                  <a:srgbClr val="0070C0"/>
+                </a:solidFill>
+                <a:latin typeface="Menlo" panose="020B0609030804020204" pitchFamily="49" charset="0"/>
+                <a:ea typeface="Menlo" panose="020B0609030804020204" pitchFamily="49" charset="0"/>
+                <a:cs typeface="Menlo" panose="020B0609030804020204" pitchFamily="49" charset="0"/>
+              </a:rPr>
+              <a:t>Success     Combinations                          Number of</a:t>
+            </a:r>
+          </a:p>
+          <a:p>
+            <a:r>
+              <a:rPr lang="en-US" sz="1200" b="1" dirty="0">
+                <a:solidFill>
+                  <a:srgbClr val="0070C0"/>
+                </a:solidFill>
+                <a:latin typeface="Menlo" panose="020B0609030804020204" pitchFamily="49" charset="0"/>
+                <a:ea typeface="Menlo" panose="020B0609030804020204" pitchFamily="49" charset="0"/>
+                <a:cs typeface="Menlo" panose="020B0609030804020204" pitchFamily="49" charset="0"/>
+              </a:rPr>
+              <a:t>count                                             Combinations</a:t>
+            </a:r>
+          </a:p>
+          <a:p>
+            <a:r>
+              <a:rPr lang="en-US" sz="1200" b="1" dirty="0">
+                <a:solidFill>
+                  <a:srgbClr val="0070C0"/>
+                </a:solidFill>
+                <a:latin typeface="Menlo" panose="020B0609030804020204" pitchFamily="49" charset="0"/>
+                <a:ea typeface="Menlo" panose="020B0609030804020204" pitchFamily="49" charset="0"/>
+                <a:cs typeface="Menlo" panose="020B0609030804020204" pitchFamily="49" charset="0"/>
+              </a:rPr>
+              <a:t>------------------------------------------------------------</a:t>
+            </a:r>
+          </a:p>
+          <a:p>
+            <a:r>
+              <a:rPr lang="en-US" sz="1200" b="1" dirty="0">
+                <a:solidFill>
+                  <a:srgbClr val="0070C0"/>
+                </a:solidFill>
+                <a:latin typeface="Menlo" panose="020B0609030804020204" pitchFamily="49" charset="0"/>
+                <a:ea typeface="Menlo" panose="020B0609030804020204" pitchFamily="49" charset="0"/>
+                <a:cs typeface="Menlo" panose="020B0609030804020204" pitchFamily="49" charset="0"/>
+              </a:rPr>
+              <a:t>  0         </a:t>
+            </a:r>
+            <a:r>
+              <a:rPr lang="en-US" sz="1200" b="1" dirty="0" err="1">
+                <a:solidFill>
+                  <a:srgbClr val="0070C0"/>
+                </a:solidFill>
+                <a:latin typeface="Menlo" panose="020B0609030804020204" pitchFamily="49" charset="0"/>
+                <a:ea typeface="Menlo" panose="020B0609030804020204" pitchFamily="49" charset="0"/>
+                <a:cs typeface="Menlo" panose="020B0609030804020204" pitchFamily="49" charset="0"/>
+              </a:rPr>
+              <a:t>oooo</a:t>
+            </a:r>
+            <a:r>
+              <a:rPr lang="en-US" sz="1200" b="1" dirty="0">
+                <a:solidFill>
+                  <a:srgbClr val="0070C0"/>
+                </a:solidFill>
+                <a:latin typeface="Menlo" panose="020B0609030804020204" pitchFamily="49" charset="0"/>
+                <a:ea typeface="Menlo" panose="020B0609030804020204" pitchFamily="49" charset="0"/>
+                <a:cs typeface="Menlo" panose="020B0609030804020204" pitchFamily="49" charset="0"/>
+              </a:rPr>
+              <a:t>                                  1 × 1 = 1</a:t>
+            </a:r>
+          </a:p>
+          <a:p>
+            <a:r>
+              <a:rPr lang="en-US" sz="1200" b="1" dirty="0">
+                <a:solidFill>
+                  <a:srgbClr val="0070C0"/>
+                </a:solidFill>
+                <a:latin typeface="Menlo" panose="020B0609030804020204" pitchFamily="49" charset="0"/>
+                <a:ea typeface="Menlo" panose="020B0609030804020204" pitchFamily="49" charset="0"/>
+                <a:cs typeface="Menlo" panose="020B0609030804020204" pitchFamily="49" charset="0"/>
+              </a:rPr>
+              <a:t>  1         </a:t>
+            </a:r>
+            <a:r>
+              <a:rPr lang="en-US" sz="1200" b="1" dirty="0" err="1">
+                <a:solidFill>
+                  <a:srgbClr val="0070C0"/>
+                </a:solidFill>
+                <a:latin typeface="Menlo" panose="020B0609030804020204" pitchFamily="49" charset="0"/>
+                <a:ea typeface="Menlo" panose="020B0609030804020204" pitchFamily="49" charset="0"/>
+                <a:cs typeface="Menlo" panose="020B0609030804020204" pitchFamily="49" charset="0"/>
+              </a:rPr>
+              <a:t>ooox</a:t>
+            </a:r>
+            <a:r>
+              <a:rPr lang="en-US" sz="1200" b="1" dirty="0">
+                <a:solidFill>
+                  <a:srgbClr val="0070C0"/>
+                </a:solidFill>
+                <a:latin typeface="Menlo" panose="020B0609030804020204" pitchFamily="49" charset="0"/>
+                <a:ea typeface="Menlo" panose="020B0609030804020204" pitchFamily="49" charset="0"/>
+                <a:cs typeface="Menlo" panose="020B0609030804020204" pitchFamily="49" charset="0"/>
+              </a:rPr>
+              <a:t>, </a:t>
+            </a:r>
+            <a:r>
+              <a:rPr lang="en-US" sz="1200" b="1" dirty="0" err="1">
+                <a:solidFill>
+                  <a:srgbClr val="0070C0"/>
+                </a:solidFill>
+                <a:latin typeface="Menlo" panose="020B0609030804020204" pitchFamily="49" charset="0"/>
+                <a:ea typeface="Menlo" panose="020B0609030804020204" pitchFamily="49" charset="0"/>
+                <a:cs typeface="Menlo" panose="020B0609030804020204" pitchFamily="49" charset="0"/>
+              </a:rPr>
+              <a:t>ooxo</a:t>
+            </a:r>
+            <a:r>
+              <a:rPr lang="en-US" sz="1200" b="1" dirty="0">
+                <a:solidFill>
+                  <a:srgbClr val="0070C0"/>
+                </a:solidFill>
+                <a:latin typeface="Menlo" panose="020B0609030804020204" pitchFamily="49" charset="0"/>
+                <a:ea typeface="Menlo" panose="020B0609030804020204" pitchFamily="49" charset="0"/>
+                <a:cs typeface="Menlo" panose="020B0609030804020204" pitchFamily="49" charset="0"/>
+              </a:rPr>
+              <a:t>, </a:t>
+            </a:r>
+            <a:r>
+              <a:rPr lang="en-US" sz="1200" b="1" dirty="0" err="1">
+                <a:solidFill>
+                  <a:srgbClr val="0070C0"/>
+                </a:solidFill>
+                <a:latin typeface="Menlo" panose="020B0609030804020204" pitchFamily="49" charset="0"/>
+                <a:ea typeface="Menlo" panose="020B0609030804020204" pitchFamily="49" charset="0"/>
+                <a:cs typeface="Menlo" panose="020B0609030804020204" pitchFamily="49" charset="0"/>
+              </a:rPr>
+              <a:t>oxoo</a:t>
+            </a:r>
+            <a:r>
+              <a:rPr lang="en-US" sz="1200" b="1" dirty="0">
+                <a:solidFill>
+                  <a:srgbClr val="0070C0"/>
+                </a:solidFill>
+                <a:latin typeface="Menlo" panose="020B0609030804020204" pitchFamily="49" charset="0"/>
+                <a:ea typeface="Menlo" panose="020B0609030804020204" pitchFamily="49" charset="0"/>
+                <a:cs typeface="Menlo" panose="020B0609030804020204" pitchFamily="49" charset="0"/>
+              </a:rPr>
+              <a:t>, </a:t>
+            </a:r>
+            <a:r>
+              <a:rPr lang="en-US" sz="1200" b="1" dirty="0" err="1">
+                <a:solidFill>
+                  <a:srgbClr val="0070C0"/>
+                </a:solidFill>
+                <a:latin typeface="Menlo" panose="020B0609030804020204" pitchFamily="49" charset="0"/>
+                <a:ea typeface="Menlo" panose="020B0609030804020204" pitchFamily="49" charset="0"/>
+                <a:cs typeface="Menlo" panose="020B0609030804020204" pitchFamily="49" charset="0"/>
+              </a:rPr>
+              <a:t>xooo</a:t>
+            </a:r>
+            <a:r>
+              <a:rPr lang="en-US" sz="1200" b="1" dirty="0">
+                <a:solidFill>
+                  <a:srgbClr val="0070C0"/>
+                </a:solidFill>
+                <a:latin typeface="Menlo" panose="020B0609030804020204" pitchFamily="49" charset="0"/>
+                <a:ea typeface="Menlo" panose="020B0609030804020204" pitchFamily="49" charset="0"/>
+                <a:cs typeface="Menlo" panose="020B0609030804020204" pitchFamily="49" charset="0"/>
+              </a:rPr>
+              <a:t>                4 × 4 = 16</a:t>
+            </a:r>
+          </a:p>
+          <a:p>
+            <a:r>
+              <a:rPr lang="en-US" sz="1200" b="1" dirty="0">
+                <a:solidFill>
+                  <a:srgbClr val="0070C0"/>
+                </a:solidFill>
+                <a:latin typeface="Menlo" panose="020B0609030804020204" pitchFamily="49" charset="0"/>
+                <a:ea typeface="Menlo" panose="020B0609030804020204" pitchFamily="49" charset="0"/>
+                <a:cs typeface="Menlo" panose="020B0609030804020204" pitchFamily="49" charset="0"/>
+              </a:rPr>
+              <a:t>  2         </a:t>
+            </a:r>
+            <a:r>
+              <a:rPr lang="en-US" sz="1200" b="1" dirty="0" err="1">
+                <a:solidFill>
+                  <a:srgbClr val="0070C0"/>
+                </a:solidFill>
+                <a:latin typeface="Menlo" panose="020B0609030804020204" pitchFamily="49" charset="0"/>
+                <a:ea typeface="Menlo" panose="020B0609030804020204" pitchFamily="49" charset="0"/>
+                <a:cs typeface="Menlo" panose="020B0609030804020204" pitchFamily="49" charset="0"/>
+              </a:rPr>
+              <a:t>ooxx</a:t>
+            </a:r>
+            <a:r>
+              <a:rPr lang="en-US" sz="1200" b="1" dirty="0">
+                <a:solidFill>
+                  <a:srgbClr val="0070C0"/>
+                </a:solidFill>
+                <a:latin typeface="Menlo" panose="020B0609030804020204" pitchFamily="49" charset="0"/>
+                <a:ea typeface="Menlo" panose="020B0609030804020204" pitchFamily="49" charset="0"/>
+                <a:cs typeface="Menlo" panose="020B0609030804020204" pitchFamily="49" charset="0"/>
+              </a:rPr>
+              <a:t>, </a:t>
+            </a:r>
+            <a:r>
+              <a:rPr lang="en-US" sz="1200" b="1" dirty="0" err="1">
+                <a:solidFill>
+                  <a:srgbClr val="0070C0"/>
+                </a:solidFill>
+                <a:latin typeface="Menlo" panose="020B0609030804020204" pitchFamily="49" charset="0"/>
+                <a:ea typeface="Menlo" panose="020B0609030804020204" pitchFamily="49" charset="0"/>
+                <a:cs typeface="Menlo" panose="020B0609030804020204" pitchFamily="49" charset="0"/>
+              </a:rPr>
+              <a:t>oxox</a:t>
+            </a:r>
+            <a:r>
+              <a:rPr lang="en-US" sz="1200" b="1" dirty="0">
+                <a:solidFill>
+                  <a:srgbClr val="0070C0"/>
+                </a:solidFill>
+                <a:latin typeface="Menlo" panose="020B0609030804020204" pitchFamily="49" charset="0"/>
+                <a:ea typeface="Menlo" panose="020B0609030804020204" pitchFamily="49" charset="0"/>
+                <a:cs typeface="Menlo" panose="020B0609030804020204" pitchFamily="49" charset="0"/>
+              </a:rPr>
+              <a:t>, </a:t>
+            </a:r>
+            <a:r>
+              <a:rPr lang="en-US" sz="1200" b="1" dirty="0" err="1">
+                <a:solidFill>
+                  <a:srgbClr val="0070C0"/>
+                </a:solidFill>
+                <a:latin typeface="Menlo" panose="020B0609030804020204" pitchFamily="49" charset="0"/>
+                <a:ea typeface="Menlo" panose="020B0609030804020204" pitchFamily="49" charset="0"/>
+                <a:cs typeface="Menlo" panose="020B0609030804020204" pitchFamily="49" charset="0"/>
+              </a:rPr>
+              <a:t>oxxo</a:t>
+            </a:r>
+            <a:r>
+              <a:rPr lang="en-US" sz="1200" b="1" dirty="0">
+                <a:solidFill>
+                  <a:srgbClr val="0070C0"/>
+                </a:solidFill>
+                <a:latin typeface="Menlo" panose="020B0609030804020204" pitchFamily="49" charset="0"/>
+                <a:ea typeface="Menlo" panose="020B0609030804020204" pitchFamily="49" charset="0"/>
+                <a:cs typeface="Menlo" panose="020B0609030804020204" pitchFamily="49" charset="0"/>
+              </a:rPr>
+              <a:t>, xoxo, </a:t>
+            </a:r>
+            <a:r>
+              <a:rPr lang="en-US" sz="1200" b="1" dirty="0" err="1">
+                <a:solidFill>
+                  <a:srgbClr val="0070C0"/>
+                </a:solidFill>
+                <a:latin typeface="Menlo" panose="020B0609030804020204" pitchFamily="49" charset="0"/>
+                <a:ea typeface="Menlo" panose="020B0609030804020204" pitchFamily="49" charset="0"/>
+                <a:cs typeface="Menlo" panose="020B0609030804020204" pitchFamily="49" charset="0"/>
+              </a:rPr>
+              <a:t>xxoo</a:t>
+            </a:r>
+            <a:r>
+              <a:rPr lang="en-US" sz="1200" b="1" dirty="0">
+                <a:solidFill>
+                  <a:srgbClr val="0070C0"/>
+                </a:solidFill>
+                <a:latin typeface="Menlo" panose="020B0609030804020204" pitchFamily="49" charset="0"/>
+                <a:ea typeface="Menlo" panose="020B0609030804020204" pitchFamily="49" charset="0"/>
+                <a:cs typeface="Menlo" panose="020B0609030804020204" pitchFamily="49" charset="0"/>
+              </a:rPr>
+              <a:t>, </a:t>
+            </a:r>
+            <a:r>
+              <a:rPr lang="en-US" sz="1200" b="1" dirty="0" err="1">
+                <a:solidFill>
+                  <a:srgbClr val="0070C0"/>
+                </a:solidFill>
+                <a:latin typeface="Menlo" panose="020B0609030804020204" pitchFamily="49" charset="0"/>
+                <a:ea typeface="Menlo" panose="020B0609030804020204" pitchFamily="49" charset="0"/>
+                <a:cs typeface="Menlo" panose="020B0609030804020204" pitchFamily="49" charset="0"/>
+              </a:rPr>
+              <a:t>xoox</a:t>
+            </a:r>
+            <a:r>
+              <a:rPr lang="en-US" sz="1200" b="1" dirty="0">
+                <a:solidFill>
+                  <a:srgbClr val="0070C0"/>
+                </a:solidFill>
+                <a:latin typeface="Menlo" panose="020B0609030804020204" pitchFamily="49" charset="0"/>
+                <a:ea typeface="Menlo" panose="020B0609030804020204" pitchFamily="49" charset="0"/>
+                <a:cs typeface="Menlo" panose="020B0609030804020204" pitchFamily="49" charset="0"/>
+              </a:rPr>
+              <a:t>    6 × 6 = 36</a:t>
+            </a:r>
+          </a:p>
+          <a:p>
+            <a:r>
+              <a:rPr lang="en-US" sz="1200" b="1" dirty="0">
+                <a:solidFill>
+                  <a:srgbClr val="0070C0"/>
+                </a:solidFill>
+                <a:latin typeface="Menlo" panose="020B0609030804020204" pitchFamily="49" charset="0"/>
+                <a:ea typeface="Menlo" panose="020B0609030804020204" pitchFamily="49" charset="0"/>
+                <a:cs typeface="Menlo" panose="020B0609030804020204" pitchFamily="49" charset="0"/>
+              </a:rPr>
+              <a:t>  3         </a:t>
+            </a:r>
+            <a:r>
+              <a:rPr lang="en-US" sz="1200" b="1" dirty="0" err="1">
+                <a:solidFill>
+                  <a:srgbClr val="0070C0"/>
+                </a:solidFill>
+                <a:latin typeface="Menlo" panose="020B0609030804020204" pitchFamily="49" charset="0"/>
+                <a:ea typeface="Menlo" panose="020B0609030804020204" pitchFamily="49" charset="0"/>
+                <a:cs typeface="Menlo" panose="020B0609030804020204" pitchFamily="49" charset="0"/>
+              </a:rPr>
+              <a:t>oxxx</a:t>
+            </a:r>
+            <a:r>
+              <a:rPr lang="en-US" sz="1200" b="1" dirty="0">
+                <a:solidFill>
+                  <a:srgbClr val="0070C0"/>
+                </a:solidFill>
+                <a:latin typeface="Menlo" panose="020B0609030804020204" pitchFamily="49" charset="0"/>
+                <a:ea typeface="Menlo" panose="020B0609030804020204" pitchFamily="49" charset="0"/>
+                <a:cs typeface="Menlo" panose="020B0609030804020204" pitchFamily="49" charset="0"/>
+              </a:rPr>
+              <a:t>, </a:t>
+            </a:r>
+            <a:r>
+              <a:rPr lang="en-US" sz="1200" b="1" dirty="0" err="1">
+                <a:solidFill>
+                  <a:srgbClr val="0070C0"/>
+                </a:solidFill>
+                <a:latin typeface="Menlo" panose="020B0609030804020204" pitchFamily="49" charset="0"/>
+                <a:ea typeface="Menlo" panose="020B0609030804020204" pitchFamily="49" charset="0"/>
+                <a:cs typeface="Menlo" panose="020B0609030804020204" pitchFamily="49" charset="0"/>
+              </a:rPr>
+              <a:t>xoxx</a:t>
+            </a:r>
+            <a:r>
+              <a:rPr lang="en-US" sz="1200" b="1" dirty="0">
+                <a:solidFill>
+                  <a:srgbClr val="0070C0"/>
+                </a:solidFill>
+                <a:latin typeface="Menlo" panose="020B0609030804020204" pitchFamily="49" charset="0"/>
+                <a:ea typeface="Menlo" panose="020B0609030804020204" pitchFamily="49" charset="0"/>
+                <a:cs typeface="Menlo" panose="020B0609030804020204" pitchFamily="49" charset="0"/>
+              </a:rPr>
+              <a:t>, </a:t>
+            </a:r>
+            <a:r>
+              <a:rPr lang="en-US" sz="1200" b="1" dirty="0" err="1">
+                <a:solidFill>
+                  <a:srgbClr val="0070C0"/>
+                </a:solidFill>
+                <a:latin typeface="Menlo" panose="020B0609030804020204" pitchFamily="49" charset="0"/>
+                <a:ea typeface="Menlo" panose="020B0609030804020204" pitchFamily="49" charset="0"/>
+                <a:cs typeface="Menlo" panose="020B0609030804020204" pitchFamily="49" charset="0"/>
+              </a:rPr>
+              <a:t>xxox</a:t>
+            </a:r>
+            <a:r>
+              <a:rPr lang="en-US" sz="1200" b="1" dirty="0">
+                <a:solidFill>
+                  <a:srgbClr val="0070C0"/>
+                </a:solidFill>
+                <a:latin typeface="Menlo" panose="020B0609030804020204" pitchFamily="49" charset="0"/>
+                <a:ea typeface="Menlo" panose="020B0609030804020204" pitchFamily="49" charset="0"/>
+                <a:cs typeface="Menlo" panose="020B0609030804020204" pitchFamily="49" charset="0"/>
+              </a:rPr>
+              <a:t>, </a:t>
+            </a:r>
+            <a:r>
+              <a:rPr lang="en-US" sz="1200" b="1" dirty="0" err="1">
+                <a:solidFill>
+                  <a:srgbClr val="0070C0"/>
+                </a:solidFill>
+                <a:latin typeface="Menlo" panose="020B0609030804020204" pitchFamily="49" charset="0"/>
+                <a:ea typeface="Menlo" panose="020B0609030804020204" pitchFamily="49" charset="0"/>
+                <a:cs typeface="Menlo" panose="020B0609030804020204" pitchFamily="49" charset="0"/>
+              </a:rPr>
+              <a:t>xxxo</a:t>
+            </a:r>
+            <a:r>
+              <a:rPr lang="en-US" sz="1200" b="1" dirty="0">
+                <a:solidFill>
+                  <a:srgbClr val="0070C0"/>
+                </a:solidFill>
+                <a:latin typeface="Menlo" panose="020B0609030804020204" pitchFamily="49" charset="0"/>
+                <a:ea typeface="Menlo" panose="020B0609030804020204" pitchFamily="49" charset="0"/>
+                <a:cs typeface="Menlo" panose="020B0609030804020204" pitchFamily="49" charset="0"/>
+              </a:rPr>
+              <a:t>                4 × 4 = 16</a:t>
+            </a:r>
+          </a:p>
+          <a:p>
+            <a:r>
+              <a:rPr lang="en-US" sz="1200" b="1" dirty="0">
+                <a:solidFill>
+                  <a:srgbClr val="0070C0"/>
+                </a:solidFill>
+                <a:latin typeface="Menlo" panose="020B0609030804020204" pitchFamily="49" charset="0"/>
+                <a:ea typeface="Menlo" panose="020B0609030804020204" pitchFamily="49" charset="0"/>
+                <a:cs typeface="Menlo" panose="020B0609030804020204" pitchFamily="49" charset="0"/>
+              </a:rPr>
+              <a:t>  4         </a:t>
+            </a:r>
+            <a:r>
+              <a:rPr lang="en-US" sz="1200" b="1" dirty="0" err="1">
+                <a:solidFill>
+                  <a:srgbClr val="0070C0"/>
+                </a:solidFill>
+                <a:latin typeface="Menlo" panose="020B0609030804020204" pitchFamily="49" charset="0"/>
+                <a:ea typeface="Menlo" panose="020B0609030804020204" pitchFamily="49" charset="0"/>
+                <a:cs typeface="Menlo" panose="020B0609030804020204" pitchFamily="49" charset="0"/>
+              </a:rPr>
+              <a:t>xxxx</a:t>
+            </a:r>
+            <a:r>
+              <a:rPr lang="en-US" sz="1200" b="1" dirty="0">
+                <a:solidFill>
+                  <a:srgbClr val="0070C0"/>
+                </a:solidFill>
+                <a:latin typeface="Menlo" panose="020B0609030804020204" pitchFamily="49" charset="0"/>
+                <a:ea typeface="Menlo" panose="020B0609030804020204" pitchFamily="49" charset="0"/>
+                <a:cs typeface="Menlo" panose="020B0609030804020204" pitchFamily="49" charset="0"/>
+              </a:rPr>
+              <a:t>                                  1 × 1 = 1</a:t>
+            </a:r>
+          </a:p>
+          <a:p>
+            <a:r>
+              <a:rPr lang="en-US" sz="1200" b="1" dirty="0">
+                <a:solidFill>
+                  <a:srgbClr val="0070C0"/>
+                </a:solidFill>
+                <a:latin typeface="Menlo" panose="020B0609030804020204" pitchFamily="49" charset="0"/>
+                <a:ea typeface="Menlo" panose="020B0609030804020204" pitchFamily="49" charset="0"/>
+                <a:cs typeface="Menlo" panose="020B0609030804020204" pitchFamily="49" charset="0"/>
+              </a:rPr>
+              <a:t>------------------------------------------------------------</a:t>
+            </a:r>
+          </a:p>
+          <a:p>
+            <a:r>
+              <a:rPr lang="en-US" sz="1200" b="1" dirty="0">
+                <a:solidFill>
+                  <a:srgbClr val="0070C0"/>
+                </a:solidFill>
+                <a:latin typeface="Menlo" panose="020B0609030804020204" pitchFamily="49" charset="0"/>
+                <a:ea typeface="Menlo" panose="020B0609030804020204" pitchFamily="49" charset="0"/>
+                <a:cs typeface="Menlo" panose="020B0609030804020204" pitchFamily="49" charset="0"/>
+              </a:rPr>
+              <a:t>Total                                                     70</a:t>
+            </a:r>
+          </a:p>
+          <a:p>
+            <a:endParaRPr lang="en-US" sz="1200" b="1" dirty="0">
+              <a:solidFill>
+                <a:srgbClr val="0070C0"/>
+              </a:solidFill>
+              <a:latin typeface="Menlo" panose="020B0609030804020204" pitchFamily="49" charset="0"/>
+              <a:ea typeface="Menlo" panose="020B0609030804020204" pitchFamily="49" charset="0"/>
+              <a:cs typeface="Menlo" panose="020B0609030804020204" pitchFamily="49" charset="0"/>
+            </a:endParaRPr>
           </a:p>
         </p:txBody>
       </p:sp>

</xml_diff>